<commit_message>
Update 이구동성 assets and add ZIP slides
Co-Authored-By: Claude Opus 4.6 (1M context) <noreply@anthropic.com>
</commit_message>
<xml_diff>
--- a/public/downloads/games/speak-together/rules.pptx
+++ b/public/downloads/games/speak-together/rules.pptx
@@ -45,16 +45,12 @@
   <p:notesSz cx="6858000" cy="9144000"/>
   <p:embeddedFontLst>
     <p:embeddedFont>
-      <p:font typeface="Jua" charset="1" panose="00000000000000000000"/>
+      <p:font typeface="무궁화 고딕" charset="1" panose="02020603020101020101"/>
       <p:regular r:id="rId41"/>
     </p:embeddedFont>
     <p:embeddedFont>
-      <p:font typeface="TDTD갬성명조" charset="1" panose="02000503000000000000"/>
+      <p:font typeface="무궁화 고딕 Bold" charset="1" panose="02020603020101020101"/>
       <p:regular r:id="rId42"/>
-    </p:embeddedFont>
-    <p:embeddedFont>
-      <p:font typeface="TDTD가온" charset="1" panose="02000503000000000000"/>
-      <p:regular r:id="rId43"/>
     </p:embeddedFont>
   </p:embeddedFontLst>
   <p:defaultTextStyle>
@@ -3172,8 +3168,8 @@
         </p:nvSpPr>
         <p:spPr>
           <a:xfrm rot="0">
-            <a:off x="1028700" y="3892867"/>
-            <a:ext cx="15555091" cy="2200275"/>
+            <a:off x="1028700" y="4178617"/>
+            <a:ext cx="15555091" cy="1914525"/>
           </a:xfrm>
           <a:prstGeom prst="rect">
             <a:avLst/>
@@ -3195,10 +3191,10 @@
                 <a:solidFill>
                   <a:srgbClr val="FFFAEF"/>
                 </a:solidFill>
-                <a:latin typeface="Jua"/>
-                <a:ea typeface="Jua"/>
-                <a:cs typeface="Jua"/>
-                <a:sym typeface="Jua"/>
+                <a:latin typeface="무궁화 고딕"/>
+                <a:ea typeface="무궁화 고딕"/>
+                <a:cs typeface="무궁화 고딕"/>
+                <a:sym typeface="무궁화 고딕"/>
               </a:rPr>
               <a:t>이구동성</a:t>
             </a:r>
@@ -3213,8 +3209,8 @@
         </p:nvSpPr>
         <p:spPr>
           <a:xfrm rot="0">
-            <a:off x="15264803" y="9812655"/>
-            <a:ext cx="2637975" cy="474345"/>
+            <a:off x="14181961" y="9822180"/>
+            <a:ext cx="3720817" cy="464820"/>
           </a:xfrm>
           <a:prstGeom prst="rect">
             <a:avLst/>
@@ -3239,10 +3235,10 @@
                 <a:solidFill>
                   <a:srgbClr val="FFFFFF"/>
                 </a:solidFill>
-                <a:latin typeface="TDTD갬성명조"/>
-                <a:ea typeface="TDTD갬성명조"/>
-                <a:cs typeface="TDTD갬성명조"/>
-                <a:sym typeface="TDTD갬성명조"/>
+                <a:latin typeface="무궁화 고딕"/>
+                <a:ea typeface="무궁화 고딕"/>
+                <a:cs typeface="무궁화 고딕"/>
+                <a:sym typeface="무궁화 고딕"/>
               </a:rPr>
               <a:t>ⓒ 2026. Sunday Play</a:t>
             </a:r>
@@ -3339,8 +3335,8 @@
         </p:nvSpPr>
         <p:spPr>
           <a:xfrm rot="0">
-            <a:off x="1135011" y="3343275"/>
-            <a:ext cx="16017978" cy="3171825"/>
+            <a:off x="1135011" y="3752850"/>
+            <a:ext cx="16017978" cy="2762250"/>
           </a:xfrm>
           <a:prstGeom prst="rect">
             <a:avLst/>
@@ -3362,10 +3358,10 @@
                 <a:solidFill>
                   <a:srgbClr val="000000"/>
                 </a:solidFill>
-                <a:latin typeface="Jua"/>
-                <a:ea typeface="Jua"/>
-                <a:cs typeface="Jua"/>
-                <a:sym typeface="Jua"/>
+                <a:latin typeface="무궁화 고딕"/>
+                <a:ea typeface="무궁화 고딕"/>
+                <a:cs typeface="무궁화 고딕"/>
+                <a:sym typeface="무궁화 고딕"/>
               </a:rPr>
               <a:t>호두</a:t>
             </a:r>
@@ -3462,8 +3458,8 @@
         </p:nvSpPr>
         <p:spPr>
           <a:xfrm rot="0">
-            <a:off x="1135011" y="3343275"/>
-            <a:ext cx="16017978" cy="3171825"/>
+            <a:off x="1135011" y="3752850"/>
+            <a:ext cx="16017978" cy="2762250"/>
           </a:xfrm>
           <a:prstGeom prst="rect">
             <a:avLst/>
@@ -3485,10 +3481,10 @@
                 <a:solidFill>
                   <a:srgbClr val="000000"/>
                 </a:solidFill>
-                <a:latin typeface="Jua"/>
-                <a:ea typeface="Jua"/>
-                <a:cs typeface="Jua"/>
-                <a:sym typeface="Jua"/>
+                <a:latin typeface="무궁화 고딕"/>
+                <a:ea typeface="무궁화 고딕"/>
+                <a:cs typeface="무궁화 고딕"/>
+                <a:sym typeface="무궁화 고딕"/>
               </a:rPr>
               <a:t>나비</a:t>
             </a:r>
@@ -3585,8 +3581,8 @@
         </p:nvSpPr>
         <p:spPr>
           <a:xfrm rot="0">
-            <a:off x="1135011" y="3343275"/>
-            <a:ext cx="16017978" cy="3171825"/>
+            <a:off x="1135011" y="3752850"/>
+            <a:ext cx="16017978" cy="2762250"/>
           </a:xfrm>
           <a:prstGeom prst="rect">
             <a:avLst/>
@@ -3608,10 +3604,10 @@
                 <a:solidFill>
                   <a:srgbClr val="000000"/>
                 </a:solidFill>
-                <a:latin typeface="Jua"/>
-                <a:ea typeface="Jua"/>
-                <a:cs typeface="Jua"/>
-                <a:sym typeface="Jua"/>
+                <a:latin typeface="무궁화 고딕"/>
+                <a:ea typeface="무궁화 고딕"/>
+                <a:cs typeface="무궁화 고딕"/>
+                <a:sym typeface="무궁화 고딕"/>
               </a:rPr>
               <a:t>두부</a:t>
             </a:r>
@@ -3708,8 +3704,8 @@
         </p:nvSpPr>
         <p:spPr>
           <a:xfrm rot="0">
-            <a:off x="1135011" y="3343275"/>
-            <a:ext cx="16017978" cy="3171825"/>
+            <a:off x="1135011" y="3752850"/>
+            <a:ext cx="16017978" cy="2762250"/>
           </a:xfrm>
           <a:prstGeom prst="rect">
             <a:avLst/>
@@ -3731,10 +3727,10 @@
                 <a:solidFill>
                   <a:srgbClr val="000000"/>
                 </a:solidFill>
-                <a:latin typeface="Jua"/>
-                <a:ea typeface="Jua"/>
-                <a:cs typeface="Jua"/>
-                <a:sym typeface="Jua"/>
+                <a:latin typeface="무궁화 고딕"/>
+                <a:ea typeface="무궁화 고딕"/>
+                <a:cs typeface="무궁화 고딕"/>
+                <a:sym typeface="무궁화 고딕"/>
               </a:rPr>
               <a:t>허리</a:t>
             </a:r>
@@ -3831,8 +3827,8 @@
         </p:nvSpPr>
         <p:spPr>
           <a:xfrm rot="0">
-            <a:off x="1135011" y="3343275"/>
-            <a:ext cx="16017978" cy="3171825"/>
+            <a:off x="1135011" y="3752850"/>
+            <a:ext cx="16017978" cy="2762250"/>
           </a:xfrm>
           <a:prstGeom prst="rect">
             <a:avLst/>
@@ -3854,10 +3850,10 @@
                 <a:solidFill>
                   <a:srgbClr val="000000"/>
                 </a:solidFill>
-                <a:latin typeface="Jua"/>
-                <a:ea typeface="Jua"/>
-                <a:cs typeface="Jua"/>
-                <a:sym typeface="Jua"/>
+                <a:latin typeface="무궁화 고딕"/>
+                <a:ea typeface="무궁화 고딕"/>
+                <a:cs typeface="무궁화 고딕"/>
+                <a:sym typeface="무궁화 고딕"/>
               </a:rPr>
               <a:t>모자</a:t>
             </a:r>
@@ -3954,8 +3950,8 @@
         </p:nvSpPr>
         <p:spPr>
           <a:xfrm rot="0">
-            <a:off x="1135011" y="3343275"/>
-            <a:ext cx="16017978" cy="3171825"/>
+            <a:off x="1135011" y="3752850"/>
+            <a:ext cx="16017978" cy="2762250"/>
           </a:xfrm>
           <a:prstGeom prst="rect">
             <a:avLst/>
@@ -3977,10 +3973,10 @@
                 <a:solidFill>
                   <a:srgbClr val="000000"/>
                 </a:solidFill>
-                <a:latin typeface="Jua"/>
-                <a:ea typeface="Jua"/>
-                <a:cs typeface="Jua"/>
-                <a:sym typeface="Jua"/>
+                <a:latin typeface="무궁화 고딕"/>
+                <a:ea typeface="무궁화 고딕"/>
+                <a:cs typeface="무궁화 고딕"/>
+                <a:sym typeface="무궁화 고딕"/>
               </a:rPr>
               <a:t>기러기</a:t>
             </a:r>
@@ -4077,8 +4073,8 @@
         </p:nvSpPr>
         <p:spPr>
           <a:xfrm rot="0">
-            <a:off x="1135011" y="3343275"/>
-            <a:ext cx="16017978" cy="3171825"/>
+            <a:off x="1135011" y="3752850"/>
+            <a:ext cx="16017978" cy="2762250"/>
           </a:xfrm>
           <a:prstGeom prst="rect">
             <a:avLst/>
@@ -4100,10 +4096,10 @@
                 <a:solidFill>
                   <a:srgbClr val="000000"/>
                 </a:solidFill>
-                <a:latin typeface="Jua"/>
-                <a:ea typeface="Jua"/>
-                <a:cs typeface="Jua"/>
-                <a:sym typeface="Jua"/>
+                <a:latin typeface="무궁화 고딕"/>
+                <a:ea typeface="무궁화 고딕"/>
+                <a:cs typeface="무궁화 고딕"/>
+                <a:sym typeface="무궁화 고딕"/>
               </a:rPr>
               <a:t>토마토</a:t>
             </a:r>
@@ -4200,8 +4196,8 @@
         </p:nvSpPr>
         <p:spPr>
           <a:xfrm rot="0">
-            <a:off x="1135011" y="3343275"/>
-            <a:ext cx="16017978" cy="3171825"/>
+            <a:off x="1135011" y="3752850"/>
+            <a:ext cx="16017978" cy="2762250"/>
           </a:xfrm>
           <a:prstGeom prst="rect">
             <a:avLst/>
@@ -4223,10 +4219,10 @@
                 <a:solidFill>
                   <a:srgbClr val="000000"/>
                 </a:solidFill>
-                <a:latin typeface="Jua"/>
-                <a:ea typeface="Jua"/>
-                <a:cs typeface="Jua"/>
-                <a:sym typeface="Jua"/>
+                <a:latin typeface="무궁화 고딕"/>
+                <a:ea typeface="무궁화 고딕"/>
+                <a:cs typeface="무궁화 고딕"/>
+                <a:sym typeface="무궁화 고딕"/>
               </a:rPr>
               <a:t>바나나</a:t>
             </a:r>
@@ -4323,8 +4319,8 @@
         </p:nvSpPr>
         <p:spPr>
           <a:xfrm rot="0">
-            <a:off x="1135011" y="3343275"/>
-            <a:ext cx="16017978" cy="3171825"/>
+            <a:off x="1135011" y="3752850"/>
+            <a:ext cx="16017978" cy="2762250"/>
           </a:xfrm>
           <a:prstGeom prst="rect">
             <a:avLst/>
@@ -4346,10 +4342,10 @@
                 <a:solidFill>
                   <a:srgbClr val="000000"/>
                 </a:solidFill>
-                <a:latin typeface="Jua"/>
-                <a:ea typeface="Jua"/>
-                <a:cs typeface="Jua"/>
-                <a:sym typeface="Jua"/>
+                <a:latin typeface="무궁화 고딕"/>
+                <a:ea typeface="무궁화 고딕"/>
+                <a:cs typeface="무궁화 고딕"/>
+                <a:sym typeface="무궁화 고딕"/>
               </a:rPr>
               <a:t>냉장고</a:t>
             </a:r>
@@ -4446,8 +4442,8 @@
         </p:nvSpPr>
         <p:spPr>
           <a:xfrm rot="0">
-            <a:off x="1135011" y="3343275"/>
-            <a:ext cx="16017978" cy="3171825"/>
+            <a:off x="1135011" y="3752850"/>
+            <a:ext cx="16017978" cy="2762250"/>
           </a:xfrm>
           <a:prstGeom prst="rect">
             <a:avLst/>
@@ -4469,10 +4465,10 @@
                 <a:solidFill>
                   <a:srgbClr val="000000"/>
                 </a:solidFill>
-                <a:latin typeface="Jua"/>
-                <a:ea typeface="Jua"/>
-                <a:cs typeface="Jua"/>
-                <a:sym typeface="Jua"/>
+                <a:latin typeface="무궁화 고딕"/>
+                <a:ea typeface="무궁화 고딕"/>
+                <a:cs typeface="무궁화 고딕"/>
+                <a:sym typeface="무궁화 고딕"/>
               </a:rPr>
               <a:t>자전거</a:t>
             </a:r>
@@ -4621,8 +4617,8 @@
         </p:nvSpPr>
         <p:spPr>
           <a:xfrm rot="0">
-            <a:off x="11392761" y="600705"/>
-            <a:ext cx="5362043" cy="1600200"/>
+            <a:off x="11392761" y="819780"/>
+            <a:ext cx="5362043" cy="1381125"/>
           </a:xfrm>
           <a:prstGeom prst="rect">
             <a:avLst/>
@@ -4644,10 +4640,10 @@
                 <a:solidFill>
                   <a:srgbClr val="FFFAEF"/>
                 </a:solidFill>
-                <a:latin typeface="Jua"/>
-                <a:ea typeface="Jua"/>
-                <a:cs typeface="Jua"/>
-                <a:sym typeface="Jua"/>
+                <a:latin typeface="무궁화 고딕"/>
+                <a:ea typeface="무궁화 고딕"/>
+                <a:cs typeface="무궁화 고딕"/>
+                <a:sym typeface="무궁화 고딕"/>
               </a:rPr>
               <a:t>규칙</a:t>
             </a:r>
@@ -4663,9 +4659,9 @@
         <p:grpSpPr>
           <a:xfrm rot="0">
             <a:off x="217650" y="223900"/>
-            <a:ext cx="8395372" cy="2942330"/>
+            <a:ext cx="8395372" cy="2601393"/>
             <a:chOff x="0" y="0"/>
-            <a:chExt cx="11193829" cy="3923107"/>
+            <a:chExt cx="11193829" cy="3468524"/>
           </a:xfrm>
         </p:grpSpPr>
         <p:sp>
@@ -4676,8 +4672,8 @@
           </p:nvSpPr>
           <p:spPr>
             <a:xfrm rot="0">
-              <a:off x="0" y="1625465"/>
-              <a:ext cx="11193829" cy="2297642"/>
+              <a:off x="0" y="1648191"/>
+              <a:ext cx="11193829" cy="1820333"/>
             </a:xfrm>
             <a:prstGeom prst="rect">
               <a:avLst/>
@@ -4691,18 +4687,18 @@
             <a:p>
               <a:pPr algn="l">
                 <a:lnSpc>
-                  <a:spcPts val="7000"/>
+                  <a:spcPts val="5599"/>
                 </a:lnSpc>
               </a:pPr>
               <a:r>
-                <a:rPr lang="en-US" sz="5000">
+                <a:rPr lang="en-US" sz="3999">
                   <a:solidFill>
                     <a:srgbClr val="FFFAEF"/>
                   </a:solidFill>
-                  <a:latin typeface="TDTD가온"/>
-                  <a:ea typeface="TDTD가온"/>
-                  <a:cs typeface="TDTD가온"/>
-                  <a:sym typeface="TDTD가온"/>
+                  <a:latin typeface="무궁화 고딕"/>
+                  <a:ea typeface="무궁화 고딕"/>
+                  <a:cs typeface="무궁화 고딕"/>
+                  <a:sym typeface="무궁화 고딕"/>
                 </a:rPr>
                 <a:t>단어의 글자 수만큼 팀원이 앞에 나와</a:t>
               </a:r>
@@ -4710,18 +4706,18 @@
             <a:p>
               <a:pPr algn="l">
                 <a:lnSpc>
-                  <a:spcPts val="7000"/>
+                  <a:spcPts val="5599"/>
                 </a:lnSpc>
               </a:pPr>
               <a:r>
-                <a:rPr lang="en-US" sz="5000">
+                <a:rPr lang="en-US" sz="3999">
                   <a:solidFill>
                     <a:srgbClr val="FFFAEF"/>
                   </a:solidFill>
-                  <a:latin typeface="TDTD가온"/>
-                  <a:ea typeface="TDTD가온"/>
-                  <a:cs typeface="TDTD가온"/>
-                  <a:sym typeface="TDTD가온"/>
+                  <a:latin typeface="무궁화 고딕"/>
+                  <a:ea typeface="무궁화 고딕"/>
+                  <a:cs typeface="무궁화 고딕"/>
+                  <a:sym typeface="무궁화 고딕"/>
                 </a:rPr>
                 <a:t>한 글자씩 담당합니다.</a:t>
               </a:r>
@@ -4736,8 +4732,8 @@
           </p:nvSpPr>
           <p:spPr>
             <a:xfrm rot="0">
-              <a:off x="0" y="-190500"/>
-              <a:ext cx="9155326" cy="1367863"/>
+              <a:off x="0" y="-66675"/>
+              <a:ext cx="9155326" cy="1238189"/>
             </a:xfrm>
             <a:prstGeom prst="rect">
               <a:avLst/>
@@ -4759,10 +4755,10 @@
                   <a:solidFill>
                     <a:srgbClr val="FFFAEF"/>
                   </a:solidFill>
-                  <a:latin typeface="Jua"/>
-                  <a:ea typeface="Jua"/>
-                  <a:cs typeface="Jua"/>
-                  <a:sym typeface="Jua"/>
+                  <a:latin typeface="무궁화 고딕 Bold"/>
+                  <a:ea typeface="무궁화 고딕 Bold"/>
+                  <a:cs typeface="무궁화 고딕 Bold"/>
+                  <a:sym typeface="무궁화 고딕 Bold"/>
                 </a:rPr>
                 <a:t>STEP 1.</a:t>
               </a:r>
@@ -4778,10 +4774,10 @@
         </p:nvGrpSpPr>
         <p:grpSpPr>
           <a:xfrm rot="0">
-            <a:off x="10708105" y="7208359"/>
-            <a:ext cx="7419474" cy="2880337"/>
+            <a:off x="10688053" y="7509148"/>
+            <a:ext cx="7419474" cy="2543787"/>
             <a:chOff x="0" y="0"/>
-            <a:chExt cx="9892632" cy="3840449"/>
+            <a:chExt cx="9892632" cy="3391716"/>
           </a:xfrm>
         </p:grpSpPr>
         <p:sp>
@@ -4792,8 +4788,8 @@
           </p:nvSpPr>
           <p:spPr>
             <a:xfrm rot="0">
-              <a:off x="0" y="1542808"/>
-              <a:ext cx="9798581" cy="2297641"/>
+              <a:off x="0" y="1571383"/>
+              <a:ext cx="9798581" cy="1820333"/>
             </a:xfrm>
             <a:prstGeom prst="rect">
               <a:avLst/>
@@ -4807,18 +4803,18 @@
             <a:p>
               <a:pPr algn="l">
                 <a:lnSpc>
-                  <a:spcPts val="7000"/>
+                  <a:spcPts val="5599"/>
                 </a:lnSpc>
               </a:pPr>
               <a:r>
-                <a:rPr lang="en-US" sz="5000">
+                <a:rPr lang="en-US" sz="3999">
                   <a:solidFill>
                     <a:srgbClr val="FFFAEF"/>
                   </a:solidFill>
-                  <a:latin typeface="TDTD가온"/>
-                  <a:ea typeface="TDTD가온"/>
-                  <a:cs typeface="TDTD가온"/>
-                  <a:sym typeface="TDTD가온"/>
+                  <a:latin typeface="무궁화 고딕"/>
+                  <a:ea typeface="무궁화 고딕"/>
+                  <a:cs typeface="무궁화 고딕"/>
+                  <a:sym typeface="무궁화 고딕"/>
                 </a:rPr>
                 <a:t>제한시간동안 가장 많은 단어를 맞춘 팀이 우승!</a:t>
               </a:r>
@@ -4833,8 +4829,8 @@
           </p:nvSpPr>
           <p:spPr>
             <a:xfrm rot="0">
-              <a:off x="0" y="-190500"/>
-              <a:ext cx="9892632" cy="1374479"/>
+              <a:off x="0" y="-57150"/>
+              <a:ext cx="9892632" cy="1241129"/>
             </a:xfrm>
             <a:prstGeom prst="rect">
               <a:avLst/>
@@ -4856,10 +4852,10 @@
                   <a:solidFill>
                     <a:srgbClr val="FFFAEF"/>
                   </a:solidFill>
-                  <a:latin typeface="Jua"/>
-                  <a:ea typeface="Jua"/>
-                  <a:cs typeface="Jua"/>
-                  <a:sym typeface="Jua"/>
+                  <a:latin typeface="무궁화 고딕 Bold"/>
+                  <a:ea typeface="무궁화 고딕 Bold"/>
+                  <a:cs typeface="무궁화 고딕 Bold"/>
+                  <a:sym typeface="무궁화 고딕 Bold"/>
                 </a:rPr>
                 <a:t>STEP 3.</a:t>
               </a:r>
@@ -4875,10 +4871,10 @@
         </p:nvGrpSpPr>
         <p:grpSpPr>
           <a:xfrm rot="0">
-            <a:off x="5458462" y="3645953"/>
-            <a:ext cx="7371077" cy="2939517"/>
+            <a:off x="5458462" y="3845084"/>
+            <a:ext cx="7371077" cy="2596832"/>
             <a:chOff x="0" y="0"/>
-            <a:chExt cx="9828103" cy="3919356"/>
+            <a:chExt cx="9828103" cy="3462442"/>
           </a:xfrm>
         </p:grpSpPr>
         <p:sp>
@@ -4889,8 +4885,8 @@
           </p:nvSpPr>
           <p:spPr>
             <a:xfrm rot="0">
-              <a:off x="0" y="1631121"/>
-              <a:ext cx="9828103" cy="2288235"/>
+              <a:off x="0" y="1642109"/>
+              <a:ext cx="9828103" cy="1820333"/>
             </a:xfrm>
             <a:prstGeom prst="rect">
               <a:avLst/>
@@ -4904,18 +4900,18 @@
             <a:p>
               <a:pPr algn="l">
                 <a:lnSpc>
-                  <a:spcPts val="6995"/>
+                  <a:spcPts val="5599"/>
                 </a:lnSpc>
               </a:pPr>
               <a:r>
-                <a:rPr lang="en-US" sz="4996">
+                <a:rPr lang="en-US" sz="3999">
                   <a:solidFill>
                     <a:srgbClr val="FFFAEF"/>
                   </a:solidFill>
-                  <a:latin typeface="TDTD가온"/>
-                  <a:ea typeface="TDTD가온"/>
-                  <a:cs typeface="TDTD가온"/>
-                  <a:sym typeface="TDTD가온"/>
+                  <a:latin typeface="무궁화 고딕"/>
+                  <a:ea typeface="무궁화 고딕"/>
+                  <a:cs typeface="무궁화 고딕"/>
+                  <a:sym typeface="무궁화 고딕"/>
                 </a:rPr>
                 <a:t>동시에 자기 글자를 외칩니다!</a:t>
               </a:r>
@@ -4923,18 +4919,18 @@
             <a:p>
               <a:pPr algn="l">
                 <a:lnSpc>
-                  <a:spcPts val="6995"/>
+                  <a:spcPts val="5599"/>
                 </a:lnSpc>
               </a:pPr>
               <a:r>
-                <a:rPr lang="en-US" sz="4996">
+                <a:rPr lang="en-US" sz="3999">
                   <a:solidFill>
                     <a:srgbClr val="FFFAEF"/>
                   </a:solidFill>
-                  <a:latin typeface="TDTD가온"/>
-                  <a:ea typeface="TDTD가온"/>
-                  <a:cs typeface="TDTD가온"/>
-                  <a:sym typeface="TDTD가온"/>
+                  <a:latin typeface="무궁화 고딕"/>
+                  <a:ea typeface="무궁화 고딕"/>
+                  <a:cs typeface="무궁화 고딕"/>
+                  <a:sym typeface="무궁화 고딕"/>
                 </a:rPr>
                 <a:t>나머지 팀원이 단어를 맞추세요!</a:t>
               </a:r>
@@ -4949,8 +4945,8 @@
           </p:nvSpPr>
           <p:spPr>
             <a:xfrm rot="0">
-              <a:off x="0" y="-190500"/>
-              <a:ext cx="5178984" cy="1369906"/>
+              <a:off x="0" y="-66675"/>
+              <a:ext cx="5178984" cy="1238018"/>
             </a:xfrm>
             <a:prstGeom prst="rect">
               <a:avLst/>
@@ -4972,10 +4968,10 @@
                   <a:solidFill>
                     <a:srgbClr val="FFFAEF"/>
                   </a:solidFill>
-                  <a:latin typeface="Jua"/>
-                  <a:ea typeface="Jua"/>
-                  <a:cs typeface="Jua"/>
-                  <a:sym typeface="Jua"/>
+                  <a:latin typeface="무궁화 고딕 Bold"/>
+                  <a:ea typeface="무궁화 고딕 Bold"/>
+                  <a:cs typeface="무궁화 고딕 Bold"/>
+                  <a:sym typeface="무궁화 고딕 Bold"/>
                 </a:rPr>
                 <a:t>STEP 2.</a:t>
               </a:r>
@@ -5073,8 +5069,8 @@
         </p:nvSpPr>
         <p:spPr>
           <a:xfrm rot="0">
-            <a:off x="1135011" y="3343275"/>
-            <a:ext cx="16017978" cy="3171825"/>
+            <a:off x="1135011" y="3752850"/>
+            <a:ext cx="16017978" cy="2762250"/>
           </a:xfrm>
           <a:prstGeom prst="rect">
             <a:avLst/>
@@ -5096,10 +5092,10 @@
                 <a:solidFill>
                   <a:srgbClr val="000000"/>
                 </a:solidFill>
-                <a:latin typeface="Jua"/>
-                <a:ea typeface="Jua"/>
-                <a:cs typeface="Jua"/>
-                <a:sym typeface="Jua"/>
+                <a:latin typeface="무궁화 고딕"/>
+                <a:ea typeface="무궁화 고딕"/>
+                <a:cs typeface="무궁화 고딕"/>
+                <a:sym typeface="무궁화 고딕"/>
               </a:rPr>
               <a:t>비행기</a:t>
             </a:r>
@@ -5196,8 +5192,8 @@
         </p:nvSpPr>
         <p:spPr>
           <a:xfrm rot="0">
-            <a:off x="1135011" y="3343275"/>
-            <a:ext cx="16017978" cy="3171825"/>
+            <a:off x="1135011" y="3752850"/>
+            <a:ext cx="16017978" cy="2762250"/>
           </a:xfrm>
           <a:prstGeom prst="rect">
             <a:avLst/>
@@ -5219,10 +5215,10 @@
                 <a:solidFill>
                   <a:srgbClr val="000000"/>
                 </a:solidFill>
-                <a:latin typeface="Jua"/>
-                <a:ea typeface="Jua"/>
-                <a:cs typeface="Jua"/>
-                <a:sym typeface="Jua"/>
+                <a:latin typeface="무궁화 고딕"/>
+                <a:ea typeface="무궁화 고딕"/>
+                <a:cs typeface="무궁화 고딕"/>
+                <a:sym typeface="무궁화 고딕"/>
               </a:rPr>
               <a:t>운동화</a:t>
             </a:r>
@@ -5319,8 +5315,8 @@
         </p:nvSpPr>
         <p:spPr>
           <a:xfrm rot="0">
-            <a:off x="1135011" y="3343275"/>
-            <a:ext cx="16017978" cy="3171825"/>
+            <a:off x="1135011" y="3752850"/>
+            <a:ext cx="16017978" cy="2762250"/>
           </a:xfrm>
           <a:prstGeom prst="rect">
             <a:avLst/>
@@ -5342,10 +5338,10 @@
                 <a:solidFill>
                   <a:srgbClr val="000000"/>
                 </a:solidFill>
-                <a:latin typeface="Jua"/>
-                <a:ea typeface="Jua"/>
-                <a:cs typeface="Jua"/>
-                <a:sym typeface="Jua"/>
+                <a:latin typeface="무궁화 고딕"/>
+                <a:ea typeface="무궁화 고딕"/>
+                <a:cs typeface="무궁화 고딕"/>
+                <a:sym typeface="무궁화 고딕"/>
               </a:rPr>
               <a:t>소방차</a:t>
             </a:r>
@@ -5442,8 +5438,8 @@
         </p:nvSpPr>
         <p:spPr>
           <a:xfrm rot="0">
-            <a:off x="1135011" y="3343275"/>
-            <a:ext cx="16017978" cy="3171825"/>
+            <a:off x="1135011" y="3752850"/>
+            <a:ext cx="16017978" cy="2762250"/>
           </a:xfrm>
           <a:prstGeom prst="rect">
             <a:avLst/>
@@ -5465,10 +5461,10 @@
                 <a:solidFill>
                   <a:srgbClr val="000000"/>
                 </a:solidFill>
-                <a:latin typeface="Jua"/>
-                <a:ea typeface="Jua"/>
-                <a:cs typeface="Jua"/>
-                <a:sym typeface="Jua"/>
+                <a:latin typeface="무궁화 고딕"/>
+                <a:ea typeface="무궁화 고딕"/>
+                <a:cs typeface="무궁화 고딕"/>
+                <a:sym typeface="무궁화 고딕"/>
               </a:rPr>
               <a:t>동물원</a:t>
             </a:r>
@@ -5565,8 +5561,8 @@
         </p:nvSpPr>
         <p:spPr>
           <a:xfrm rot="0">
-            <a:off x="1135011" y="3343275"/>
-            <a:ext cx="16017978" cy="3171825"/>
+            <a:off x="1135011" y="3752850"/>
+            <a:ext cx="16017978" cy="2762250"/>
           </a:xfrm>
           <a:prstGeom prst="rect">
             <a:avLst/>
@@ -5588,10 +5584,10 @@
                 <a:solidFill>
                   <a:srgbClr val="000000"/>
                 </a:solidFill>
-                <a:latin typeface="Jua"/>
-                <a:ea typeface="Jua"/>
-                <a:cs typeface="Jua"/>
-                <a:sym typeface="Jua"/>
+                <a:latin typeface="무궁화 고딕"/>
+                <a:ea typeface="무궁화 고딕"/>
+                <a:cs typeface="무궁화 고딕"/>
+                <a:sym typeface="무궁화 고딕"/>
               </a:rPr>
               <a:t>수영장</a:t>
             </a:r>
@@ -5688,8 +5684,8 @@
         </p:nvSpPr>
         <p:spPr>
           <a:xfrm rot="0">
-            <a:off x="1135011" y="3343275"/>
-            <a:ext cx="16017978" cy="3171825"/>
+            <a:off x="1135011" y="3752850"/>
+            <a:ext cx="16017978" cy="2762250"/>
           </a:xfrm>
           <a:prstGeom prst="rect">
             <a:avLst/>
@@ -5711,10 +5707,10 @@
                 <a:solidFill>
                   <a:srgbClr val="000000"/>
                 </a:solidFill>
-                <a:latin typeface="Jua"/>
-                <a:ea typeface="Jua"/>
-                <a:cs typeface="Jua"/>
-                <a:sym typeface="Jua"/>
+                <a:latin typeface="무궁화 고딕"/>
+                <a:ea typeface="무궁화 고딕"/>
+                <a:cs typeface="무궁화 고딕"/>
+                <a:sym typeface="무궁화 고딕"/>
               </a:rPr>
               <a:t>대한민국</a:t>
             </a:r>
@@ -5811,8 +5807,8 @@
         </p:nvSpPr>
         <p:spPr>
           <a:xfrm rot="0">
-            <a:off x="1135011" y="3343275"/>
-            <a:ext cx="16017978" cy="3171825"/>
+            <a:off x="1135011" y="3752850"/>
+            <a:ext cx="16017978" cy="2762250"/>
           </a:xfrm>
           <a:prstGeom prst="rect">
             <a:avLst/>
@@ -5834,10 +5830,10 @@
                 <a:solidFill>
                   <a:srgbClr val="000000"/>
                 </a:solidFill>
-                <a:latin typeface="Jua"/>
-                <a:ea typeface="Jua"/>
-                <a:cs typeface="Jua"/>
-                <a:sym typeface="Jua"/>
+                <a:latin typeface="무궁화 고딕"/>
+                <a:ea typeface="무궁화 고딕"/>
+                <a:cs typeface="무궁화 고딕"/>
+                <a:sym typeface="무궁화 고딕"/>
               </a:rPr>
               <a:t>놀이공원</a:t>
             </a:r>
@@ -5934,8 +5930,8 @@
         </p:nvSpPr>
         <p:spPr>
           <a:xfrm rot="0">
-            <a:off x="1135011" y="3343275"/>
-            <a:ext cx="16017978" cy="3171825"/>
+            <a:off x="1135011" y="3752850"/>
+            <a:ext cx="16017978" cy="2762250"/>
           </a:xfrm>
           <a:prstGeom prst="rect">
             <a:avLst/>
@@ -5957,10 +5953,10 @@
                 <a:solidFill>
                   <a:srgbClr val="000000"/>
                 </a:solidFill>
-                <a:latin typeface="Jua"/>
-                <a:ea typeface="Jua"/>
-                <a:cs typeface="Jua"/>
-                <a:sym typeface="Jua"/>
+                <a:latin typeface="무궁화 고딕"/>
+                <a:ea typeface="무궁화 고딕"/>
+                <a:cs typeface="무궁화 고딕"/>
+                <a:sym typeface="무궁화 고딕"/>
               </a:rPr>
               <a:t>수학여행</a:t>
             </a:r>
@@ -6057,8 +6053,8 @@
         </p:nvSpPr>
         <p:spPr>
           <a:xfrm rot="0">
-            <a:off x="1135011" y="3343275"/>
-            <a:ext cx="16017978" cy="3171825"/>
+            <a:off x="1135011" y="3752850"/>
+            <a:ext cx="16017978" cy="2762250"/>
           </a:xfrm>
           <a:prstGeom prst="rect">
             <a:avLst/>
@@ -6080,10 +6076,10 @@
                 <a:solidFill>
                   <a:srgbClr val="000000"/>
                 </a:solidFill>
-                <a:latin typeface="Jua"/>
-                <a:ea typeface="Jua"/>
-                <a:cs typeface="Jua"/>
-                <a:sym typeface="Jua"/>
+                <a:latin typeface="무궁화 고딕"/>
+                <a:ea typeface="무궁화 고딕"/>
+                <a:cs typeface="무궁화 고딕"/>
+                <a:sym typeface="무궁화 고딕"/>
               </a:rPr>
               <a:t>할렐루야</a:t>
             </a:r>
@@ -6180,8 +6176,8 @@
         </p:nvSpPr>
         <p:spPr>
           <a:xfrm rot="0">
-            <a:off x="1135011" y="3343275"/>
-            <a:ext cx="16017978" cy="3171825"/>
+            <a:off x="1135011" y="3752850"/>
+            <a:ext cx="16017978" cy="2762250"/>
           </a:xfrm>
           <a:prstGeom prst="rect">
             <a:avLst/>
@@ -6203,10 +6199,10 @@
                 <a:solidFill>
                   <a:srgbClr val="000000"/>
                 </a:solidFill>
-                <a:latin typeface="Jua"/>
-                <a:ea typeface="Jua"/>
-                <a:cs typeface="Jua"/>
-                <a:sym typeface="Jua"/>
+                <a:latin typeface="무궁화 고딕"/>
+                <a:ea typeface="무궁화 고딕"/>
+                <a:cs typeface="무궁화 고딕"/>
+                <a:sym typeface="무궁화 고딕"/>
               </a:rPr>
               <a:t>고속도로</a:t>
             </a:r>
@@ -6253,8 +6249,8 @@
         </p:nvSpPr>
         <p:spPr>
           <a:xfrm rot="0">
-            <a:off x="3238925" y="4092795"/>
-            <a:ext cx="11810151" cy="2200275"/>
+            <a:off x="3238925" y="4378545"/>
+            <a:ext cx="11810151" cy="1914525"/>
           </a:xfrm>
           <a:prstGeom prst="rect">
             <a:avLst/>
@@ -6276,10 +6272,10 @@
                 <a:solidFill>
                   <a:srgbClr val="000000"/>
                 </a:solidFill>
-                <a:latin typeface="Jua"/>
-                <a:ea typeface="Jua"/>
-                <a:cs typeface="Jua"/>
-                <a:sym typeface="Jua"/>
+                <a:latin typeface="무궁화 고딕"/>
+                <a:ea typeface="무궁화 고딕"/>
+                <a:cs typeface="무궁화 고딕"/>
+                <a:sym typeface="무궁화 고딕"/>
               </a:rPr>
               <a:t>팀을 나눠주세요!</a:t>
             </a:r>
@@ -6426,8 +6422,8 @@
         </p:nvSpPr>
         <p:spPr>
           <a:xfrm rot="0">
-            <a:off x="1135011" y="3343275"/>
-            <a:ext cx="16017978" cy="3171825"/>
+            <a:off x="1135011" y="3752850"/>
+            <a:ext cx="16017978" cy="2762250"/>
           </a:xfrm>
           <a:prstGeom prst="rect">
             <a:avLst/>
@@ -6449,10 +6445,10 @@
                 <a:solidFill>
                   <a:srgbClr val="000000"/>
                 </a:solidFill>
-                <a:latin typeface="Jua"/>
-                <a:ea typeface="Jua"/>
-                <a:cs typeface="Jua"/>
-                <a:sym typeface="Jua"/>
+                <a:latin typeface="무궁화 고딕"/>
+                <a:ea typeface="무궁화 고딕"/>
+                <a:cs typeface="무궁화 고딕"/>
+                <a:sym typeface="무궁화 고딕"/>
               </a:rPr>
               <a:t>코카콜라</a:t>
             </a:r>
@@ -6549,8 +6545,8 @@
         </p:nvSpPr>
         <p:spPr>
           <a:xfrm rot="0">
-            <a:off x="1135011" y="3343275"/>
-            <a:ext cx="16017978" cy="3171825"/>
+            <a:off x="1135011" y="3752850"/>
+            <a:ext cx="16017978" cy="2762250"/>
           </a:xfrm>
           <a:prstGeom prst="rect">
             <a:avLst/>
@@ -6572,10 +6568,10 @@
                 <a:solidFill>
                   <a:srgbClr val="000000"/>
                 </a:solidFill>
-                <a:latin typeface="Jua"/>
-                <a:ea typeface="Jua"/>
-                <a:cs typeface="Jua"/>
-                <a:sym typeface="Jua"/>
+                <a:latin typeface="무궁화 고딕"/>
+                <a:ea typeface="무궁화 고딕"/>
+                <a:cs typeface="무궁화 고딕"/>
+                <a:sym typeface="무궁화 고딕"/>
               </a:rPr>
               <a:t>고구마빵</a:t>
             </a:r>
@@ -6672,8 +6668,8 @@
         </p:nvSpPr>
         <p:spPr>
           <a:xfrm rot="0">
-            <a:off x="1135011" y="3343275"/>
-            <a:ext cx="16017978" cy="3171825"/>
+            <a:off x="1135011" y="3752850"/>
+            <a:ext cx="16017978" cy="2762250"/>
           </a:xfrm>
           <a:prstGeom prst="rect">
             <a:avLst/>
@@ -6695,10 +6691,10 @@
                 <a:solidFill>
                   <a:srgbClr val="000000"/>
                 </a:solidFill>
-                <a:latin typeface="Jua"/>
-                <a:ea typeface="Jua"/>
-                <a:cs typeface="Jua"/>
-                <a:sym typeface="Jua"/>
+                <a:latin typeface="무궁화 고딕"/>
+                <a:ea typeface="무궁화 고딕"/>
+                <a:cs typeface="무궁화 고딕"/>
+                <a:sym typeface="무궁화 고딕"/>
               </a:rPr>
               <a:t>주일학교</a:t>
             </a:r>
@@ -6795,8 +6791,8 @@
         </p:nvSpPr>
         <p:spPr>
           <a:xfrm rot="0">
-            <a:off x="1135011" y="3343275"/>
-            <a:ext cx="16017978" cy="3171825"/>
+            <a:off x="1135011" y="3752850"/>
+            <a:ext cx="16017978" cy="2762250"/>
           </a:xfrm>
           <a:prstGeom prst="rect">
             <a:avLst/>
@@ -6818,10 +6814,10 @@
                 <a:solidFill>
                   <a:srgbClr val="000000"/>
                 </a:solidFill>
-                <a:latin typeface="Jua"/>
-                <a:ea typeface="Jua"/>
-                <a:cs typeface="Jua"/>
-                <a:sym typeface="Jua"/>
+                <a:latin typeface="무궁화 고딕"/>
+                <a:ea typeface="무궁화 고딕"/>
+                <a:cs typeface="무궁화 고딕"/>
+                <a:sym typeface="무궁화 고딕"/>
               </a:rPr>
               <a:t>동방박사</a:t>
             </a:r>
@@ -6918,8 +6914,8 @@
         </p:nvSpPr>
         <p:spPr>
           <a:xfrm rot="0">
-            <a:off x="1135011" y="3343275"/>
-            <a:ext cx="16017978" cy="3171825"/>
+            <a:off x="1135011" y="3752850"/>
+            <a:ext cx="16017978" cy="2762250"/>
           </a:xfrm>
           <a:prstGeom prst="rect">
             <a:avLst/>
@@ -6941,10 +6937,10 @@
                 <a:solidFill>
                   <a:srgbClr val="000000"/>
                 </a:solidFill>
-                <a:latin typeface="Jua"/>
-                <a:ea typeface="Jua"/>
-                <a:cs typeface="Jua"/>
-                <a:sym typeface="Jua"/>
+                <a:latin typeface="무궁화 고딕"/>
+                <a:ea typeface="무궁화 고딕"/>
+                <a:cs typeface="무궁화 고딕"/>
+                <a:sym typeface="무궁화 고딕"/>
               </a:rPr>
               <a:t>초등학교</a:t>
             </a:r>
@@ -7016,8 +7012,8 @@
         </p:nvSpPr>
         <p:spPr>
           <a:xfrm rot="0">
-            <a:off x="4421807" y="3895725"/>
-            <a:ext cx="9444385" cy="2200275"/>
+            <a:off x="4421807" y="4181475"/>
+            <a:ext cx="9444385" cy="1914525"/>
           </a:xfrm>
           <a:prstGeom prst="rect">
             <a:avLst/>
@@ -7039,10 +7035,10 @@
                 <a:solidFill>
                   <a:srgbClr val="000000"/>
                 </a:solidFill>
-                <a:latin typeface="Jua"/>
-                <a:ea typeface="Jua"/>
-                <a:cs typeface="Jua"/>
-                <a:sym typeface="Jua"/>
+                <a:latin typeface="무궁화 고딕"/>
+                <a:ea typeface="무궁화 고딕"/>
+                <a:cs typeface="무궁화 고딕"/>
+                <a:sym typeface="무궁화 고딕"/>
               </a:rPr>
               <a:t>감사합니다!</a:t>
             </a:r>
@@ -7189,8 +7185,8 @@
         </p:nvSpPr>
         <p:spPr>
           <a:xfrm rot="0">
-            <a:off x="1028700" y="3892867"/>
-            <a:ext cx="15555091" cy="2200275"/>
+            <a:off x="1028700" y="4178617"/>
+            <a:ext cx="15555091" cy="1914525"/>
           </a:xfrm>
           <a:prstGeom prst="rect">
             <a:avLst/>
@@ -7212,10 +7208,10 @@
                 <a:solidFill>
                   <a:srgbClr val="FFFAEF"/>
                 </a:solidFill>
-                <a:latin typeface="Jua"/>
-                <a:ea typeface="Jua"/>
-                <a:cs typeface="Jua"/>
-                <a:sym typeface="Jua"/>
+                <a:latin typeface="무궁화 고딕"/>
+                <a:ea typeface="무궁화 고딕"/>
+                <a:cs typeface="무궁화 고딕"/>
+                <a:sym typeface="무궁화 고딕"/>
               </a:rPr>
               <a:t>이구동성</a:t>
             </a:r>
@@ -7230,8 +7226,8 @@
         </p:nvSpPr>
         <p:spPr>
           <a:xfrm rot="0">
-            <a:off x="15264803" y="9812655"/>
-            <a:ext cx="2637975" cy="474345"/>
+            <a:off x="14181961" y="9822180"/>
+            <a:ext cx="3720817" cy="464820"/>
           </a:xfrm>
           <a:prstGeom prst="rect">
             <a:avLst/>
@@ -7256,10 +7252,10 @@
                 <a:solidFill>
                   <a:srgbClr val="FFFFFF"/>
                 </a:solidFill>
-                <a:latin typeface="TDTD갬성명조"/>
-                <a:ea typeface="TDTD갬성명조"/>
-                <a:cs typeface="TDTD갬성명조"/>
-                <a:sym typeface="TDTD갬성명조"/>
+                <a:latin typeface="무궁화 고딕"/>
+                <a:ea typeface="무궁화 고딕"/>
+                <a:cs typeface="무궁화 고딕"/>
+                <a:sym typeface="무궁화 고딕"/>
               </a:rPr>
               <a:t>ⓒ 2026. Sunday Play</a:t>
             </a:r>
@@ -7356,8 +7352,8 @@
         </p:nvSpPr>
         <p:spPr>
           <a:xfrm rot="0">
-            <a:off x="1135011" y="3343275"/>
-            <a:ext cx="16017978" cy="3171825"/>
+            <a:off x="1135011" y="3752850"/>
+            <a:ext cx="16017978" cy="2762250"/>
           </a:xfrm>
           <a:prstGeom prst="rect">
             <a:avLst/>
@@ -7379,10 +7375,10 @@
                 <a:solidFill>
                   <a:srgbClr val="000000"/>
                 </a:solidFill>
-                <a:latin typeface="Jua"/>
-                <a:ea typeface="Jua"/>
-                <a:cs typeface="Jua"/>
-                <a:sym typeface="Jua"/>
+                <a:latin typeface="무궁화 고딕"/>
+                <a:ea typeface="무궁화 고딕"/>
+                <a:cs typeface="무궁화 고딕"/>
+                <a:sym typeface="무궁화 고딕"/>
               </a:rPr>
               <a:t>오이</a:t>
             </a:r>
@@ -7479,8 +7475,8 @@
         </p:nvSpPr>
         <p:spPr>
           <a:xfrm rot="0">
-            <a:off x="1135011" y="3343275"/>
-            <a:ext cx="16017978" cy="3171825"/>
+            <a:off x="1135011" y="3752850"/>
+            <a:ext cx="16017978" cy="2762250"/>
           </a:xfrm>
           <a:prstGeom prst="rect">
             <a:avLst/>
@@ -7502,10 +7498,10 @@
                 <a:solidFill>
                   <a:srgbClr val="000000"/>
                 </a:solidFill>
-                <a:latin typeface="Jua"/>
-                <a:ea typeface="Jua"/>
-                <a:cs typeface="Jua"/>
-                <a:sym typeface="Jua"/>
+                <a:latin typeface="무궁화 고딕"/>
+                <a:ea typeface="무궁화 고딕"/>
+                <a:cs typeface="무궁화 고딕"/>
+                <a:sym typeface="무궁화 고딕"/>
               </a:rPr>
               <a:t>바다</a:t>
             </a:r>
@@ -7602,8 +7598,8 @@
         </p:nvSpPr>
         <p:spPr>
           <a:xfrm rot="0">
-            <a:off x="1135011" y="3343275"/>
-            <a:ext cx="16017978" cy="3171825"/>
+            <a:off x="1135011" y="3752850"/>
+            <a:ext cx="16017978" cy="2762250"/>
           </a:xfrm>
           <a:prstGeom prst="rect">
             <a:avLst/>
@@ -7625,10 +7621,10 @@
                 <a:solidFill>
                   <a:srgbClr val="000000"/>
                 </a:solidFill>
-                <a:latin typeface="Jua"/>
-                <a:ea typeface="Jua"/>
-                <a:cs typeface="Jua"/>
-                <a:sym typeface="Jua"/>
+                <a:latin typeface="무궁화 고딕"/>
+                <a:ea typeface="무궁화 고딕"/>
+                <a:cs typeface="무궁화 고딕"/>
+                <a:sym typeface="무궁화 고딕"/>
               </a:rPr>
               <a:t>우유</a:t>
             </a:r>
@@ -7725,8 +7721,8 @@
         </p:nvSpPr>
         <p:spPr>
           <a:xfrm rot="0">
-            <a:off x="1135011" y="3343275"/>
-            <a:ext cx="16017978" cy="3171825"/>
+            <a:off x="1135011" y="3752850"/>
+            <a:ext cx="16017978" cy="2762250"/>
           </a:xfrm>
           <a:prstGeom prst="rect">
             <a:avLst/>
@@ -7748,10 +7744,10 @@
                 <a:solidFill>
                   <a:srgbClr val="000000"/>
                 </a:solidFill>
-                <a:latin typeface="Jua"/>
-                <a:ea typeface="Jua"/>
-                <a:cs typeface="Jua"/>
-                <a:sym typeface="Jua"/>
+                <a:latin typeface="무궁화 고딕"/>
+                <a:ea typeface="무궁화 고딕"/>
+                <a:cs typeface="무궁화 고딕"/>
+                <a:sym typeface="무궁화 고딕"/>
               </a:rPr>
               <a:t>피자</a:t>
             </a:r>
@@ -7848,8 +7844,8 @@
         </p:nvSpPr>
         <p:spPr>
           <a:xfrm rot="0">
-            <a:off x="1135011" y="3343275"/>
-            <a:ext cx="16017978" cy="3171825"/>
+            <a:off x="1135011" y="3752850"/>
+            <a:ext cx="16017978" cy="2762250"/>
           </a:xfrm>
           <a:prstGeom prst="rect">
             <a:avLst/>
@@ -7871,10 +7867,10 @@
                 <a:solidFill>
                   <a:srgbClr val="000000"/>
                 </a:solidFill>
-                <a:latin typeface="Jua"/>
-                <a:ea typeface="Jua"/>
-                <a:cs typeface="Jua"/>
-                <a:sym typeface="Jua"/>
+                <a:latin typeface="무궁화 고딕"/>
+                <a:ea typeface="무궁화 고딕"/>
+                <a:cs typeface="무궁화 고딕"/>
+                <a:sym typeface="무궁화 고딕"/>
               </a:rPr>
               <a:t>치마</a:t>
             </a:r>

</xml_diff>